<commit_message>
chore: move tp to docs
</commit_message>
<xml_diff>
--- a/docs/presentation/Avances_Tutor_Academico_TP2.pptx
+++ b/docs/presentation/Avances_Tutor_Academico_TP2.pptx
@@ -4077,14 +4077,14 @@
           <p:nvPr>
             <p:extLst>
               <p:ext uri="{D42A27DB-BD31-4B8C-83A1-F6EECF244321}">
-                <p14:modId xmlns:p14="http://schemas.microsoft.com/office/powerpoint/2010/main" val="82583015"/>
+                <p14:modId xmlns:p14="http://schemas.microsoft.com/office/powerpoint/2010/main" val="3460034960"/>
               </p:ext>
             </p:extLst>
           </p:nvPr>
         </p:nvGraphicFramePr>
         <p:xfrm>
           <a:off x="502920" y="1828800"/>
-          <a:ext cx="11155680" cy="4297680"/>
+          <a:ext cx="11155680" cy="4297682"/>
         </p:xfrm>
         <a:graphic>
           <a:graphicData uri="http://schemas.openxmlformats.org/drawingml/2006/table">
@@ -4130,8 +4130,10 @@
                         </a:defRPr>
                       </a:pPr>
                       <a:r>
+                        <a:rPr dirty="0" err="1"/>
                         <a:t>Épica</a:t>
                       </a:r>
+                      <a:endParaRPr dirty="0"/>
                     </a:p>
                   </a:txBody>
                   <a:tcPr anchor="ctr">
@@ -4154,8 +4156,10 @@
                         </a:defRPr>
                       </a:pPr>
                       <a:r>
+                        <a:rPr dirty="0" err="1"/>
                         <a:t>Componente</a:t>
                       </a:r>
+                      <a:endParaRPr dirty="0"/>
                     </a:p>
                   </a:txBody>
                   <a:tcPr anchor="ctr">
@@ -4178,6 +4182,7 @@
                         </a:defRPr>
                       </a:pPr>
                       <a:r>
+                        <a:rPr dirty="0"/>
                         <a:t>Estado</a:t>
                       </a:r>
                     </a:p>
@@ -4312,8 +4317,10 @@
                         </a:defRPr>
                       </a:pPr>
                       <a:r>
+                        <a:rPr dirty="0" err="1"/>
                         <a:t>Ingestor</a:t>
                       </a:r>
+                      <a:endParaRPr dirty="0"/>
                     </a:p>
                   </a:txBody>
                   <a:tcPr anchor="ctr">
@@ -4391,8 +4398,10 @@
                         </a:defRPr>
                       </a:pPr>
                       <a:r>
+                        <a:rPr dirty="0" err="1"/>
                         <a:t>ExamGenerator</a:t>
                       </a:r>
+                      <a:endParaRPr dirty="0"/>
                     </a:p>
                   </a:txBody>
                   <a:tcPr anchor="ctr">
@@ -4573,7 +4582,16 @@
                         </a:defRPr>
                       </a:pPr>
                       <a:r>
-                        <a:t>✅  en dev</a:t>
+                        <a:rPr dirty="0"/>
+                        <a:t>✅  </a:t>
+                      </a:r>
+                      <a:r>
+                        <a:rPr dirty="0" err="1"/>
+                        <a:t>en</a:t>
+                      </a:r>
+                      <a:r>
+                        <a:rPr dirty="0"/>
+                        <a:t> dev</a:t>
                       </a:r>
                     </a:p>
                   </a:txBody>
@@ -4604,6 +4622,7 @@
                         </a:defRPr>
                       </a:pPr>
                       <a:r>
+                        <a:rPr dirty="0"/>
                         <a:t>06</a:t>
                       </a:r>
                     </a:p>
@@ -4628,6 +4647,7 @@
                         </a:defRPr>
                       </a:pPr>
                       <a:r>
+                        <a:rPr dirty="0"/>
                         <a:t>Support Agent</a:t>
                       </a:r>
                     </a:p>
@@ -4652,7 +4672,16 @@
                         </a:defRPr>
                       </a:pPr>
                       <a:r>
-                        <a:t>✅  en dev</a:t>
+                        <a:rPr dirty="0"/>
+                        <a:t>✅  </a:t>
+                      </a:r>
+                      <a:r>
+                        <a:rPr dirty="0" err="1"/>
+                        <a:t>en</a:t>
+                      </a:r>
+                      <a:r>
+                        <a:rPr dirty="0"/>
+                        <a:t> dev</a:t>
                       </a:r>
                     </a:p>
                   </a:txBody>
@@ -4683,13 +4712,14 @@
                         </a:defRPr>
                       </a:pPr>
                       <a:r>
+                        <a:rPr dirty="0"/>
                         <a:t>07</a:t>
                       </a:r>
                     </a:p>
                   </a:txBody>
                   <a:tcPr anchor="ctr">
                     <a:solidFill>
-                      <a:srgbClr val="FFFFFF"/>
+                      <a:schemeClr val="bg1"/>
                     </a:solidFill>
                   </a:tcPr>
                 </a:tc>
@@ -4707,13 +4737,14 @@
                         </a:defRPr>
                       </a:pPr>
                       <a:r>
+                        <a:rPr dirty="0"/>
                         <a:t>UI — Next.js</a:t>
                       </a:r>
                     </a:p>
                   </a:txBody>
                   <a:tcPr anchor="ctr">
                     <a:solidFill>
-                      <a:srgbClr val="FFFFFF"/>
+                      <a:schemeClr val="bg1"/>
                     </a:solidFill>
                   </a:tcPr>
                 </a:tc>
@@ -4743,13 +4774,13 @@
                   </a:txBody>
                   <a:tcPr anchor="ctr">
                     <a:solidFill>
-                      <a:srgbClr val="FFFFFF"/>
+                      <a:schemeClr val="bg1"/>
                     </a:solidFill>
                   </a:tcPr>
                 </a:tc>
                 <a:extLst>
                   <a:ext uri="{0D108BD9-81ED-4DB2-BD59-A6C34878D82A}">
-                    <a16:rowId xmlns:a16="http://schemas.microsoft.com/office/drawing/2014/main" val="10007"/>
+                    <a16:rowId xmlns:a16="http://schemas.microsoft.com/office/drawing/2014/main" val="4025467862"/>
                   </a:ext>
                 </a:extLst>
               </a:tr>
@@ -4768,92 +4799,14 @@
                         </a:defRPr>
                       </a:pPr>
                       <a:r>
-                        <a:t>10</a:t>
-                      </a:r>
-                    </a:p>
-                  </a:txBody>
-                  <a:tcPr anchor="ctr">
-                    <a:solidFill>
-                      <a:srgbClr val="F5F3FF"/>
-                    </a:solidFill>
-                  </a:tcPr>
-                </a:tc>
-                <a:tc>
-                  <a:txBody>
-                    <a:bodyPr/>
-                    <a:lstStyle/>
-                    <a:p>
-                      <a:pPr>
-                        <a:defRPr sz="1250" b="0">
-                          <a:solidFill>
-                            <a:srgbClr val="1F2937"/>
-                          </a:solidFill>
-                          <a:latin typeface="Calibri"/>
-                        </a:defRPr>
-                      </a:pPr>
-                      <a:r>
-                        <a:t>Refactor de arquitectura</a:t>
-                      </a:r>
-                    </a:p>
-                  </a:txBody>
-                  <a:tcPr anchor="ctr">
-                    <a:solidFill>
-                      <a:srgbClr val="F5F3FF"/>
-                    </a:solidFill>
-                  </a:tcPr>
-                </a:tc>
-                <a:tc>
-                  <a:txBody>
-                    <a:bodyPr/>
-                    <a:lstStyle/>
-                    <a:p>
-                      <a:pPr>
-                        <a:defRPr sz="1250" b="1">
-                          <a:solidFill>
-                            <a:srgbClr val="10B981"/>
-                          </a:solidFill>
-                          <a:latin typeface="Calibri"/>
-                        </a:defRPr>
-                      </a:pPr>
-                      <a:r>
-                        <a:t>✅  en dev</a:t>
-                      </a:r>
-                    </a:p>
-                  </a:txBody>
-                  <a:tcPr anchor="ctr">
-                    <a:solidFill>
-                      <a:srgbClr val="F5F3FF"/>
-                    </a:solidFill>
-                  </a:tcPr>
-                </a:tc>
-                <a:extLst>
-                  <a:ext uri="{0D108BD9-81ED-4DB2-BD59-A6C34878D82A}">
-                    <a16:rowId xmlns:a16="http://schemas.microsoft.com/office/drawing/2014/main" val="10008"/>
-                  </a:ext>
-                </a:extLst>
-              </a:tr>
-              <a:tr h="390698">
-                <a:tc>
-                  <a:txBody>
-                    <a:bodyPr/>
-                    <a:lstStyle/>
-                    <a:p>
-                      <a:pPr>
-                        <a:defRPr sz="1250" b="1">
-                          <a:solidFill>
-                            <a:srgbClr val="4F46E5"/>
-                          </a:solidFill>
-                          <a:latin typeface="Calibri"/>
-                        </a:defRPr>
-                      </a:pPr>
-                      <a:r>
+                        <a:rPr dirty="0"/>
                         <a:t>08</a:t>
                       </a:r>
                     </a:p>
                   </a:txBody>
                   <a:tcPr anchor="ctr">
                     <a:solidFill>
-                      <a:srgbClr val="FFFFFF"/>
+                      <a:srgbClr val="EEEAF2"/>
                     </a:solidFill>
                   </a:tcPr>
                 </a:tc>
@@ -4877,7 +4830,7 @@
                   </a:txBody>
                   <a:tcPr anchor="ctr">
                     <a:solidFill>
-                      <a:srgbClr val="FFFFFF"/>
+                      <a:srgbClr val="EEEAF2"/>
                     </a:solidFill>
                   </a:tcPr>
                 </a:tc>
@@ -4895,13 +4848,27 @@
                         </a:defRPr>
                       </a:pPr>
                       <a:r>
-                        <a:t>⏳  feat/epic-08 · en progreso</a:t>
+                        <a:rPr dirty="0"/>
+                        <a:t>⏳  feat/epic-08 · </a:t>
                       </a:r>
+                      <a:r>
+                        <a:rPr dirty="0" err="1"/>
+                        <a:t>en</a:t>
+                      </a:r>
+                      <a:r>
+                        <a:rPr dirty="0"/>
+                        <a:t> </a:t>
+                      </a:r>
+                      <a:r>
+                        <a:rPr dirty="0" err="1"/>
+                        <a:t>progreso</a:t>
+                      </a:r>
+                      <a:endParaRPr dirty="0"/>
                     </a:p>
                   </a:txBody>
                   <a:tcPr anchor="ctr">
                     <a:solidFill>
-                      <a:srgbClr val="FFFFFF"/>
+                      <a:srgbClr val="EEEAF2"/>
                     </a:solidFill>
                   </a:tcPr>
                 </a:tc>
@@ -4926,13 +4893,14 @@
                         </a:defRPr>
                       </a:pPr>
                       <a:r>
+                        <a:rPr dirty="0"/>
                         <a:t>09</a:t>
                       </a:r>
                     </a:p>
                   </a:txBody>
                   <a:tcPr anchor="ctr">
                     <a:solidFill>
-                      <a:srgbClr val="F5F3FF"/>
+                      <a:schemeClr val="bg1"/>
                     </a:solidFill>
                   </a:tcPr>
                 </a:tc>
@@ -4956,7 +4924,7 @@
                   </a:txBody>
                   <a:tcPr anchor="ctr">
                     <a:solidFill>
-                      <a:srgbClr val="F5F3FF"/>
+                      <a:schemeClr val="bg1"/>
                     </a:solidFill>
                   </a:tcPr>
                 </a:tc>
@@ -4986,13 +4954,108 @@
                   </a:txBody>
                   <a:tcPr anchor="ctr">
                     <a:solidFill>
+                      <a:schemeClr val="bg1"/>
+                    </a:solidFill>
+                  </a:tcPr>
+                </a:tc>
+                <a:extLst>
+                  <a:ext uri="{0D108BD9-81ED-4DB2-BD59-A6C34878D82A}">
+                    <a16:rowId xmlns:a16="http://schemas.microsoft.com/office/drawing/2014/main" val="10010"/>
+                  </a:ext>
+                </a:extLst>
+              </a:tr>
+              <a:tr h="390700">
+                <a:tc>
+                  <a:txBody>
+                    <a:bodyPr/>
+                    <a:lstStyle/>
+                    <a:p>
+                      <a:pPr>
+                        <a:defRPr sz="1250" b="1">
+                          <a:solidFill>
+                            <a:srgbClr val="4F46E5"/>
+                          </a:solidFill>
+                          <a:latin typeface="Calibri"/>
+                        </a:defRPr>
+                      </a:pPr>
+                      <a:r>
+                        <a:rPr dirty="0"/>
+                        <a:t>10</a:t>
+                      </a:r>
+                    </a:p>
+                  </a:txBody>
+                  <a:tcPr anchor="ctr">
+                    <a:solidFill>
+                      <a:srgbClr val="F5F3FF"/>
+                    </a:solidFill>
+                  </a:tcPr>
+                </a:tc>
+                <a:tc>
+                  <a:txBody>
+                    <a:bodyPr/>
+                    <a:lstStyle/>
+                    <a:p>
+                      <a:pPr>
+                        <a:defRPr sz="1250" b="0">
+                          <a:solidFill>
+                            <a:srgbClr val="1F2937"/>
+                          </a:solidFill>
+                          <a:latin typeface="Calibri"/>
+                        </a:defRPr>
+                      </a:pPr>
+                      <a:r>
+                        <a:rPr dirty="0"/>
+                        <a:t>Refactor de </a:t>
+                      </a:r>
+                      <a:r>
+                        <a:rPr dirty="0" err="1"/>
+                        <a:t>arquitectura</a:t>
+                      </a:r>
+                      <a:endParaRPr dirty="0"/>
+                    </a:p>
+                  </a:txBody>
+                  <a:tcPr anchor="ctr">
+                    <a:solidFill>
+                      <a:srgbClr val="F5F3FF"/>
+                    </a:solidFill>
+                  </a:tcPr>
+                </a:tc>
+                <a:tc>
+                  <a:txBody>
+                    <a:bodyPr/>
+                    <a:lstStyle/>
+                    <a:p>
+                      <a:pPr>
+                        <a:defRPr sz="1250" b="1">
+                          <a:solidFill>
+                            <a:srgbClr val="10B981"/>
+                          </a:solidFill>
+                          <a:latin typeface="Calibri"/>
+                        </a:defRPr>
+                      </a:pPr>
+                      <a:r>
+                        <a:rPr dirty="0"/>
+                        <a:t>✅  </a:t>
+                      </a:r>
+                      <a:r>
+                        <a:rPr dirty="0" err="1"/>
+                        <a:t>en</a:t>
+                      </a:r>
+                      <a:r>
+                        <a:rPr dirty="0"/>
+                        <a:t> dev</a:t>
+                      </a:r>
+                    </a:p>
+                  </a:txBody>
+                  <a:tcPr anchor="ctr">
+                    <a:solidFill>
                       <a:srgbClr val="F5F3FF"/>
                     </a:solidFill>
                   </a:tcPr>
                 </a:tc>
                 <a:extLst>
                   <a:ext uri="{0D108BD9-81ED-4DB2-BD59-A6C34878D82A}">
-                    <a16:rowId xmlns:a16="http://schemas.microsoft.com/office/drawing/2014/main" val="10010"/>
+                    <a16:rowId xmlns:a16="http://schemas.microsoft.com/office/drawing/2014/main" val="3237913801"/>
                   </a:ext>
                 </a:extLst>
               </a:tr>

</xml_diff>